<commit_message>
Apply unified visual palette across deliverables
</commit_message>
<xml_diff>
--- a/presentation/Smart_Power_Final_Presentation.pptx
+++ b/presentation/Smart_Power_Final_Presentation.pptx
@@ -2,22 +2,22 @@
 <file path=ppt/presentation.xml><?xml version="1.0" encoding="utf-8"?>
 <p:presentation xmlns:p="http://schemas.openxmlformats.org/presentationml/2006/main">
   <p:sldMasterIdLst>
-    <p:sldMasterId xmlns:r="http://schemas.openxmlformats.org/officeDocument/2006/relationships" id="2147483648" r:id="R7c41aae226204a41"/>
+    <p:sldMasterId xmlns:r="http://schemas.openxmlformats.org/officeDocument/2006/relationships" id="2147483648" r:id="R65e673010cf44053"/>
   </p:sldMasterIdLst>
   <p:notesMasterIdLst>
-    <p:notesMasterId xmlns:r="http://schemas.openxmlformats.org/officeDocument/2006/relationships" r:id="Radd5e94d13804b2d"/>
+    <p:notesMasterId xmlns:r="http://schemas.openxmlformats.org/officeDocument/2006/relationships" r:id="Rdd1841f248b34587"/>
   </p:notesMasterIdLst>
   <p:sldIdLst>
-    <p:sldId xmlns:r="http://schemas.openxmlformats.org/officeDocument/2006/relationships" id="256" r:id="Rf2054cc51aeb4f31"/>
-    <p:sldId xmlns:r="http://schemas.openxmlformats.org/officeDocument/2006/relationships" id="257" r:id="R4c812620fca44034"/>
-    <p:sldId xmlns:r="http://schemas.openxmlformats.org/officeDocument/2006/relationships" id="258" r:id="R53a8032ddfce4372"/>
-    <p:sldId xmlns:r="http://schemas.openxmlformats.org/officeDocument/2006/relationships" id="259" r:id="Rc62c8b188f494459"/>
-    <p:sldId xmlns:r="http://schemas.openxmlformats.org/officeDocument/2006/relationships" id="260" r:id="R729363a000874b16"/>
-    <p:sldId xmlns:r="http://schemas.openxmlformats.org/officeDocument/2006/relationships" id="261" r:id="R3a44a5d859b649ee"/>
-    <p:sldId xmlns:r="http://schemas.openxmlformats.org/officeDocument/2006/relationships" id="262" r:id="Rec391d4ffd784d66"/>
-    <p:sldId xmlns:r="http://schemas.openxmlformats.org/officeDocument/2006/relationships" id="263" r:id="R810dcfa32f5a4160"/>
-    <p:sldId xmlns:r="http://schemas.openxmlformats.org/officeDocument/2006/relationships" id="264" r:id="R8fcdca15f5e24082"/>
-    <p:sldId xmlns:r="http://schemas.openxmlformats.org/officeDocument/2006/relationships" id="265" r:id="R2eb784b2effa40c7"/>
+    <p:sldId xmlns:r="http://schemas.openxmlformats.org/officeDocument/2006/relationships" id="256" r:id="Re519fb928d934922"/>
+    <p:sldId xmlns:r="http://schemas.openxmlformats.org/officeDocument/2006/relationships" id="257" r:id="Rfd1c1f99396c43db"/>
+    <p:sldId xmlns:r="http://schemas.openxmlformats.org/officeDocument/2006/relationships" id="258" r:id="R36c7c22a37514889"/>
+    <p:sldId xmlns:r="http://schemas.openxmlformats.org/officeDocument/2006/relationships" id="259" r:id="Ree9c7d34ac41481e"/>
+    <p:sldId xmlns:r="http://schemas.openxmlformats.org/officeDocument/2006/relationships" id="260" r:id="R391976ba0249439d"/>
+    <p:sldId xmlns:r="http://schemas.openxmlformats.org/officeDocument/2006/relationships" id="261" r:id="Ra545160ec8334c73"/>
+    <p:sldId xmlns:r="http://schemas.openxmlformats.org/officeDocument/2006/relationships" id="262" r:id="R3bc359cde11a4095"/>
+    <p:sldId xmlns:r="http://schemas.openxmlformats.org/officeDocument/2006/relationships" id="263" r:id="R62e2a2f7bfb0474b"/>
+    <p:sldId xmlns:r="http://schemas.openxmlformats.org/officeDocument/2006/relationships" id="264" r:id="R0f009fdcabaa49bf"/>
+    <p:sldId xmlns:r="http://schemas.openxmlformats.org/officeDocument/2006/relationships" id="265" r:id="R624018797aca4e13"/>
   </p:sldIdLst>
   <p:sldSz cx="12192000" cy="6858000"/>
   <p:notesSz cx="6858000" cy="9144000"/>
@@ -1354,7 +1354,7 @@
   </p:cSld>
   <p:clrMap bg1="lt1" tx1="dk1" bg2="lt2" tx2="dk2" accent1="accent1" accent2="accent2" accent3="accent3" accent4="accent4" accent5="accent5" accent6="accent6" hlink="hlink" folHlink="folHlink"/>
   <p:sldLayoutIdLst>
-    <p:sldLayoutId xmlns:r="http://schemas.openxmlformats.org/officeDocument/2006/relationships" id="2147483649" r:id="R15a619414bc2401b"/>
+    <p:sldLayoutId xmlns:r="http://schemas.openxmlformats.org/officeDocument/2006/relationships" id="2147483649" r:id="Rb629cf8f23284e76"/>
   </p:sldLayoutIdLst>
   <p:txStyles>
     <p:titleStyle>
@@ -1898,7 +1898,7 @@
           </c:tx>
           <c:spPr>
             <a:solidFill xmlns:a="http://schemas.openxmlformats.org/drawingml/2006/main">
-              <a:srgbClr val="6DCBF4"/>
+              <a:srgbClr val="81C2A8"/>
             </a:solidFill>
           </c:spPr>
           <c:cat>
@@ -1945,7 +1945,7 @@
           </c:tx>
           <c:spPr>
             <a:solidFill xmlns:a="http://schemas.openxmlformats.org/drawingml/2006/main">
-              <a:srgbClr val="3D8DFF"/>
+              <a:srgbClr val="36676B"/>
             </a:solidFill>
           </c:spPr>
           <c:cat>
@@ -2129,7 +2129,7 @@
           </c:tx>
           <c:spPr>
             <a:solidFill xmlns:a="http://schemas.openxmlformats.org/drawingml/2006/main">
-              <a:srgbClr val="C9AEF2"/>
+              <a:srgbClr val="36676B"/>
             </a:solidFill>
           </c:spPr>
           <c:cat>
@@ -2297,7 +2297,7 @@
           </c:tx>
           <c:spPr>
             <a:solidFill xmlns:a="http://schemas.openxmlformats.org/drawingml/2006/main">
-              <a:srgbClr val="F28E2B"/>
+              <a:srgbClr val="F09D46"/>
             </a:solidFill>
           </c:spPr>
           <c:cat>
@@ -2604,7 +2604,7 @@
           <c:spPr>
             <a:ln xmlns:a="http://schemas.openxmlformats.org/drawingml/2006/main" w="28575">
               <a:solidFill>
-                <a:srgbClr val="3D8DFF"/>
+                <a:srgbClr val="36676B"/>
               </a:solidFill>
               <a:prstDash val="solid"/>
             </a:ln>
@@ -2614,7 +2614,7 @@
             <c:size val="6"/>
             <c:spPr>
               <a:solidFill xmlns:a="http://schemas.openxmlformats.org/drawingml/2006/main">
-                <a:srgbClr val="3D8DFF"/>
+                <a:srgbClr val="36676B"/>
               </a:solidFill>
             </c:spPr>
           </c:marker>
@@ -2663,7 +2663,7 @@
           <c:spPr>
             <a:ln xmlns:a="http://schemas.openxmlformats.org/drawingml/2006/main" w="28575">
               <a:solidFill>
-                <a:srgbClr val="D0EDFA"/>
+                <a:srgbClr val="E8F4EF"/>
               </a:solidFill>
               <a:prstDash val="solid"/>
             </a:ln>
@@ -2673,7 +2673,7 @@
             <c:size val="6"/>
             <c:spPr>
               <a:solidFill xmlns:a="http://schemas.openxmlformats.org/drawingml/2006/main">
-                <a:srgbClr val="D0EDFA"/>
+                <a:srgbClr val="E8F4EF"/>
               </a:solidFill>
             </c:spPr>
           </c:marker>
@@ -2857,7 +2857,7 @@
           </c:tx>
           <c:spPr>
             <a:solidFill xmlns:a="http://schemas.openxmlformats.org/drawingml/2006/main">
-              <a:srgbClr val="F28E2B"/>
+              <a:srgbClr val="AF5622"/>
             </a:solidFill>
           </c:spPr>
           <c:cat>
@@ -2892,7 +2892,7 @@
           </c:tx>
           <c:spPr>
             <a:solidFill xmlns:a="http://schemas.openxmlformats.org/drawingml/2006/main">
-              <a:srgbClr val="26ABA4"/>
+              <a:srgbClr val="81C2A8"/>
             </a:solidFill>
           </c:spPr>
           <c:invertIfNegative val="0"/>
@@ -3220,7 +3220,7 @@
             <a:r>
               <a:rPr sz="1800" b="1">
                 <a:solidFill>
-                  <a:srgbClr val="26ABA4"/>
+                  <a:srgbClr val="215138"/>
                 </a:solidFill>
                 <a:latin typeface="Helvetica Neue"/>
                 <a:ea typeface="Helvetica Neue"/>
@@ -3254,11 +3254,11 @@
             <a:avLst/>
           </a:prstGeom>
           <a:solidFill xmlns:a="http://schemas.openxmlformats.org/drawingml/2006/main">
-            <a:srgbClr val="26ABA4"/>
+            <a:srgbClr val="215138"/>
           </a:solidFill>
           <a:ln xmlns:a="http://schemas.openxmlformats.org/drawingml/2006/main" w="0">
             <a:solidFill>
-              <a:srgbClr val="26ABA4"/>
+              <a:srgbClr val="215138"/>
             </a:solidFill>
             <a:prstDash val="solid"/>
           </a:ln>
@@ -3501,7 +3501,7 @@
             <a:r>
               <a:rPr sz="1800" b="1">
                 <a:solidFill>
-                  <a:srgbClr val="26ABA4"/>
+                  <a:srgbClr val="215138"/>
                 </a:solidFill>
                 <a:latin typeface="Helvetica Neue"/>
                 <a:ea typeface="Helvetica Neue"/>
@@ -3535,11 +3535,11 @@
             <a:avLst/>
           </a:prstGeom>
           <a:solidFill xmlns:a="http://schemas.openxmlformats.org/drawingml/2006/main">
-            <a:srgbClr val="26ABA4"/>
+            <a:srgbClr val="215138"/>
           </a:solidFill>
           <a:ln xmlns:a="http://schemas.openxmlformats.org/drawingml/2006/main" w="0">
             <a:solidFill>
-              <a:srgbClr val="26ABA4"/>
+              <a:srgbClr val="215138"/>
             </a:solidFill>
             <a:prstDash val="solid"/>
           </a:ln>
@@ -3616,7 +3616,7 @@
             <a:r>
               <a:rPr sz="2100" b="1">
                 <a:solidFill>
-                  <a:srgbClr val="26ABA4"/>
+                  <a:srgbClr val="215138"/>
                 </a:solidFill>
                 <a:latin typeface="Helvetica Neue"/>
                 <a:ea typeface="Helvetica Neue"/>
@@ -3744,6 +3744,7 @@
           <a:lstStyle xmlns:a="http://schemas.openxmlformats.org/drawingml/2006/main"/>
           <a:p xmlns:a="http://schemas.openxmlformats.org/drawingml/2006/main">
             <a:pPr algn="r">
+              <a:buNone/>
               <a:defRPr sz="1000">
                 <a:solidFill>
                   <a:srgbClr val="000000"/>
@@ -3865,7 +3866,7 @@
             <a:r>
               <a:rPr sz="2100" b="1">
                 <a:solidFill>
-                  <a:srgbClr val="F28E2B"/>
+                  <a:srgbClr val="F09D46"/>
                 </a:solidFill>
                 <a:latin typeface="Helvetica Neue"/>
                 <a:ea typeface="Helvetica Neue"/>
@@ -3958,11 +3959,11 @@
             <a:avLst/>
           </a:prstGeom>
           <a:solidFill xmlns:a="http://schemas.openxmlformats.org/drawingml/2006/main">
-            <a:srgbClr val="F28E2B"/>
+            <a:srgbClr val="F09D46"/>
           </a:solidFill>
           <a:ln xmlns:a="http://schemas.openxmlformats.org/drawingml/2006/main" w="0">
             <a:solidFill>
-              <a:srgbClr val="F28E2B"/>
+              <a:srgbClr val="F09D46"/>
             </a:solidFill>
             <a:prstDash val="solid"/>
           </a:ln>
@@ -4018,6 +4019,7 @@
           <a:lstStyle xmlns:a="http://schemas.openxmlformats.org/drawingml/2006/main"/>
           <a:p xmlns:a="http://schemas.openxmlformats.org/drawingml/2006/main">
             <a:pPr algn="r">
+              <a:buNone/>
               <a:defRPr sz="1000">
                 <a:solidFill>
                   <a:srgbClr val="000000"/>
@@ -4092,7 +4094,7 @@
       </p:sp>
       <p:cxnSp>
         <p:nvCxnSpPr>
-          <p:cNvPr id="16" name="Google-Shape-2259-p159-4"/>
+          <p:cNvPr id="22" name="Google-Shape-2259-p159-4"/>
           <p:cNvCxnSpPr/>
           <p:nvPr/>
         </p:nvCxnSpPr>
@@ -4239,7 +4241,7 @@
             <a:r>
               <a:rPr sz="1425" b="1">
                 <a:solidFill>
-                  <a:srgbClr val="26ABA4"/>
+                  <a:srgbClr val="215138"/>
                 </a:solidFill>
                 <a:latin typeface="Helvetica Neue"/>
                 <a:ea typeface="Helvetica Neue"/>
@@ -4296,7 +4298,7 @@
             <a:r>
               <a:rPr sz="1425" b="1">
                 <a:solidFill>
-                  <a:srgbClr val="F28E2B"/>
+                  <a:srgbClr val="F09D46"/>
                 </a:solidFill>
                 <a:latin typeface="Helvetica Neue"/>
                 <a:ea typeface="Helvetica Neue"/>
@@ -4353,7 +4355,7 @@
             <a:r>
               <a:rPr sz="1425" b="1">
                 <a:solidFill>
-                  <a:srgbClr val="C9AEF2"/>
+                  <a:srgbClr val="36676B"/>
                 </a:solidFill>
                 <a:latin typeface="Helvetica Neue"/>
                 <a:ea typeface="Helvetica Neue"/>
@@ -4648,11 +4650,11 @@
             <a:avLst/>
           </a:prstGeom>
           <a:solidFill xmlns:a="http://schemas.openxmlformats.org/drawingml/2006/main">
-            <a:srgbClr val="26ABA4"/>
+            <a:srgbClr val="215138"/>
           </a:solidFill>
           <a:ln xmlns:a="http://schemas.openxmlformats.org/drawingml/2006/main" w="0">
             <a:solidFill>
-              <a:srgbClr val="26ABA4"/>
+              <a:srgbClr val="215138"/>
             </a:solidFill>
             <a:prstDash val="solid"/>
           </a:ln>
@@ -4795,6 +4797,7 @@
           <a:lstStyle xmlns:a="http://schemas.openxmlformats.org/drawingml/2006/main"/>
           <a:p xmlns:a="http://schemas.openxmlformats.org/drawingml/2006/main">
             <a:pPr algn="r">
+              <a:buNone/>
               <a:defRPr sz="1000">
                 <a:solidFill>
                   <a:srgbClr val="000000"/>
@@ -5258,7 +5261,7 @@
             <a:r>
               <a:rPr sz="1350" b="1">
                 <a:solidFill>
-                  <a:srgbClr val="26ABA4"/>
+                  <a:srgbClr val="215138"/>
                 </a:solidFill>
                 <a:latin typeface="Helvetica Neue"/>
                 <a:ea typeface="Helvetica Neue"/>
@@ -5319,11 +5322,11 @@
             <a:avLst/>
           </a:prstGeom>
           <a:solidFill xmlns:a="http://schemas.openxmlformats.org/drawingml/2006/main">
-            <a:srgbClr val="C9AEF2"/>
+            <a:srgbClr val="36676B"/>
           </a:solidFill>
           <a:ln xmlns:a="http://schemas.openxmlformats.org/drawingml/2006/main" w="0">
             <a:solidFill>
-              <a:srgbClr val="C9AEF2"/>
+              <a:srgbClr val="36676B"/>
             </a:solidFill>
             <a:prstDash val="solid"/>
           </a:ln>
@@ -5381,6 +5384,7 @@
           <a:lstStyle xmlns:a="http://schemas.openxmlformats.org/drawingml/2006/main"/>
           <a:p xmlns:a="http://schemas.openxmlformats.org/drawingml/2006/main">
             <a:pPr algn="r">
+              <a:buNone/>
               <a:defRPr sz="1000">
                 <a:solidFill>
                   <a:srgbClr val="000000"/>
@@ -5803,7 +5807,7 @@
       </p:sp>
       <p:graphicFrame>
         <p:nvGraphicFramePr>
-          <p:cNvPr id="21" name="Chart"/>
+          <p:cNvPr id="24" name="Chart"/>
           <p:cNvGraphicFramePr/>
           <p:nvPr/>
         </p:nvGraphicFramePr>
@@ -5813,7 +5817,7 @@
         </p:xfrm>
         <a:graphic xmlns:a="http://schemas.openxmlformats.org/drawingml/2006/main">
           <a:graphicData uri="http://schemas.openxmlformats.org/drawingml/2006/chart">
-            <c:chart xmlns:r="http://schemas.openxmlformats.org/officeDocument/2006/relationships" xmlns:c="http://schemas.openxmlformats.org/drawingml/2006/chart" r:id="R2d75d181b1d044eb"/>
+            <c:chart xmlns:r="http://schemas.openxmlformats.org/officeDocument/2006/relationships" xmlns:c="http://schemas.openxmlformats.org/drawingml/2006/chart" r:id="Rf241ae8c757249aa"/>
           </a:graphicData>
         </a:graphic>
       </p:graphicFrame>
@@ -5852,7 +5856,7 @@
       </p:sp>
       <p:graphicFrame>
         <p:nvGraphicFramePr>
-          <p:cNvPr id="23" name="Chart"/>
+          <p:cNvPr id="26" name="Chart"/>
           <p:cNvGraphicFramePr/>
           <p:nvPr/>
         </p:nvGraphicFramePr>
@@ -5862,7 +5866,7 @@
         </p:xfrm>
         <a:graphic xmlns:a="http://schemas.openxmlformats.org/drawingml/2006/main">
           <a:graphicData uri="http://schemas.openxmlformats.org/drawingml/2006/chart">
-            <c:chart xmlns:r="http://schemas.openxmlformats.org/officeDocument/2006/relationships" xmlns:c="http://schemas.openxmlformats.org/drawingml/2006/chart" r:id="Rec5589af0bef4449"/>
+            <c:chart xmlns:r="http://schemas.openxmlformats.org/officeDocument/2006/relationships" xmlns:c="http://schemas.openxmlformats.org/drawingml/2006/chart" r:id="R5f7a5aa2d4394844"/>
           </a:graphicData>
         </a:graphic>
       </p:graphicFrame>
@@ -5889,11 +5893,11 @@
             <a:avLst/>
           </a:prstGeom>
           <a:solidFill xmlns:a="http://schemas.openxmlformats.org/drawingml/2006/main">
-            <a:srgbClr val="F28E2B"/>
+            <a:srgbClr val="F09D46"/>
           </a:solidFill>
           <a:ln xmlns:a="http://schemas.openxmlformats.org/drawingml/2006/main" w="0">
             <a:solidFill>
-              <a:srgbClr val="F28E2B"/>
+              <a:srgbClr val="F09D46"/>
             </a:solidFill>
             <a:prstDash val="solid"/>
           </a:ln>
@@ -5949,6 +5953,7 @@
           <a:lstStyle xmlns:a="http://schemas.openxmlformats.org/drawingml/2006/main"/>
           <a:p xmlns:a="http://schemas.openxmlformats.org/drawingml/2006/main">
             <a:pPr algn="r">
+              <a:buNone/>
               <a:defRPr sz="1000">
                 <a:solidFill>
                   <a:srgbClr val="000000"/>
@@ -6096,7 +6101,7 @@
             <a:r>
               <a:rPr sz="3150" b="1">
                 <a:solidFill>
-                  <a:srgbClr val="F28E2B"/>
+                  <a:srgbClr val="AF5622"/>
                 </a:solidFill>
                 <a:latin typeface="Helvetica Neue"/>
                 <a:ea typeface="Helvetica Neue"/>
@@ -6240,7 +6245,7 @@
             <a:r>
               <a:rPr sz="3150" b="1">
                 <a:solidFill>
-                  <a:srgbClr val="26ABA4"/>
+                  <a:srgbClr val="215138"/>
                 </a:solidFill>
                 <a:latin typeface="Helvetica Neue"/>
                 <a:ea typeface="Helvetica Neue"/>
@@ -6297,7 +6302,7 @@
             <a:r>
               <a:rPr sz="1350" b="0">
                 <a:solidFill>
-                  <a:srgbClr val="000000"/>
+                  <a:srgbClr val="215138"/>
                 </a:solidFill>
                 <a:latin typeface="Helvetica Neue"/>
                 <a:ea typeface="Helvetica Neue"/>
@@ -6368,7 +6373,7 @@
       </p:sp>
       <p:graphicFrame>
         <p:nvGraphicFramePr>
-          <p:cNvPr id="23" name="Chart"/>
+          <p:cNvPr id="26" name="Chart"/>
           <p:cNvGraphicFramePr/>
           <p:nvPr/>
         </p:nvGraphicFramePr>
@@ -6378,7 +6383,7 @@
         </p:xfrm>
         <a:graphic xmlns:a="http://schemas.openxmlformats.org/drawingml/2006/main">
           <a:graphicData uri="http://schemas.openxmlformats.org/drawingml/2006/chart">
-            <c:chart xmlns:r="http://schemas.openxmlformats.org/officeDocument/2006/relationships" xmlns:c="http://schemas.openxmlformats.org/drawingml/2006/chart" r:id="R404eb13733ec48e1"/>
+            <c:chart xmlns:r="http://schemas.openxmlformats.org/officeDocument/2006/relationships" xmlns:c="http://schemas.openxmlformats.org/drawingml/2006/chart" r:id="Raeda1d25f42540e9"/>
           </a:graphicData>
         </a:graphic>
       </p:graphicFrame>
@@ -6417,7 +6422,7 @@
       </p:sp>
       <p:graphicFrame>
         <p:nvGraphicFramePr>
-          <p:cNvPr id="25" name="Chart"/>
+          <p:cNvPr id="28" name="Chart"/>
           <p:cNvGraphicFramePr/>
           <p:nvPr/>
         </p:nvGraphicFramePr>
@@ -6427,7 +6432,7 @@
         </p:xfrm>
         <a:graphic xmlns:a="http://schemas.openxmlformats.org/drawingml/2006/main">
           <a:graphicData uri="http://schemas.openxmlformats.org/drawingml/2006/chart">
-            <c:chart xmlns:r="http://schemas.openxmlformats.org/officeDocument/2006/relationships" xmlns:c="http://schemas.openxmlformats.org/drawingml/2006/chart" r:id="Rb9f4dce5b564489f"/>
+            <c:chart xmlns:r="http://schemas.openxmlformats.org/officeDocument/2006/relationships" xmlns:c="http://schemas.openxmlformats.org/drawingml/2006/chart" r:id="R3e0e1a855bbd4601"/>
           </a:graphicData>
         </a:graphic>
       </p:graphicFrame>
@@ -6454,11 +6459,11 @@
             <a:avLst/>
           </a:prstGeom>
           <a:solidFill xmlns:a="http://schemas.openxmlformats.org/drawingml/2006/main">
-            <a:srgbClr val="26ABA4"/>
+            <a:srgbClr val="215138"/>
           </a:solidFill>
           <a:ln xmlns:a="http://schemas.openxmlformats.org/drawingml/2006/main" w="0">
             <a:solidFill>
-              <a:srgbClr val="26ABA4"/>
+              <a:srgbClr val="215138"/>
             </a:solidFill>
             <a:prstDash val="solid"/>
           </a:ln>
@@ -6514,6 +6519,7 @@
           <a:lstStyle xmlns:a="http://schemas.openxmlformats.org/drawingml/2006/main"/>
           <a:p xmlns:a="http://schemas.openxmlformats.org/drawingml/2006/main">
             <a:pPr algn="r">
+              <a:buNone/>
               <a:defRPr sz="1000">
                 <a:solidFill>
                   <a:srgbClr val="000000"/>
@@ -6661,7 +6667,7 @@
             <a:r>
               <a:rPr sz="1350" b="1">
                 <a:solidFill>
-                  <a:srgbClr val="26ABA4"/>
+                  <a:srgbClr val="215138"/>
                 </a:solidFill>
                 <a:latin typeface="Helvetica Neue"/>
                 <a:ea typeface="Helvetica Neue"/>
@@ -6948,7 +6954,7 @@
             <a:r>
               <a:rPr sz="1350" b="1">
                 <a:solidFill>
-                  <a:srgbClr val="F28E2B"/>
+                  <a:srgbClr val="F09D46"/>
                 </a:solidFill>
                 <a:latin typeface="Helvetica Neue"/>
                 <a:ea typeface="Helvetica Neue"/>
@@ -7235,7 +7241,7 @@
             <a:r>
               <a:rPr sz="1350" b="1">
                 <a:solidFill>
-                  <a:srgbClr val="C9AEF2"/>
+                  <a:srgbClr val="36676B"/>
                 </a:solidFill>
                 <a:latin typeface="Helvetica Neue"/>
                 <a:ea typeface="Helvetica Neue"/>
@@ -7470,11 +7476,11 @@
             <a:avLst/>
           </a:prstGeom>
           <a:solidFill xmlns:a="http://schemas.openxmlformats.org/drawingml/2006/main">
-            <a:srgbClr val="C9AEF2"/>
+            <a:srgbClr val="36676B"/>
           </a:solidFill>
           <a:ln xmlns:a="http://schemas.openxmlformats.org/drawingml/2006/main" w="0">
             <a:solidFill>
-              <a:srgbClr val="C9AEF2"/>
+              <a:srgbClr val="36676B"/>
             </a:solidFill>
             <a:prstDash val="solid"/>
           </a:ln>
@@ -7551,7 +7557,7 @@
             <a:r>
               <a:rPr sz="2100" b="1">
                 <a:solidFill>
-                  <a:srgbClr val="C9AEF2"/>
+                  <a:srgbClr val="36676B"/>
                 </a:solidFill>
                 <a:latin typeface="Helvetica Neue"/>
                 <a:ea typeface="Helvetica Neue"/>
@@ -7679,6 +7685,7 @@
           <a:lstStyle xmlns:a="http://schemas.openxmlformats.org/drawingml/2006/main"/>
           <a:p xmlns:a="http://schemas.openxmlformats.org/drawingml/2006/main">
             <a:pPr algn="r">
+              <a:buNone/>
               <a:defRPr sz="1000">
                 <a:solidFill>
                   <a:srgbClr val="000000"/>
@@ -7800,7 +7807,7 @@
             <a:r>
               <a:rPr sz="2100" b="1">
                 <a:solidFill>
-                  <a:srgbClr val="26ABA4"/>
+                  <a:srgbClr val="215138"/>
                 </a:solidFill>
                 <a:latin typeface="Helvetica Neue"/>
                 <a:ea typeface="Helvetica Neue"/>
@@ -7891,11 +7898,11 @@
             <a:avLst/>
           </a:prstGeom>
           <a:solidFill xmlns:a="http://schemas.openxmlformats.org/drawingml/2006/main">
-            <a:srgbClr val="26ABA4"/>
+            <a:srgbClr val="215138"/>
           </a:solidFill>
           <a:ln xmlns:a="http://schemas.openxmlformats.org/drawingml/2006/main" w="0">
             <a:solidFill>
-              <a:srgbClr val="26ABA4"/>
+              <a:srgbClr val="215138"/>
             </a:solidFill>
             <a:prstDash val="solid"/>
           </a:ln>
@@ -7953,6 +7960,7 @@
           <a:lstStyle xmlns:a="http://schemas.openxmlformats.org/drawingml/2006/main"/>
           <a:p xmlns:a="http://schemas.openxmlformats.org/drawingml/2006/main">
             <a:pPr algn="r">
+              <a:buNone/>
               <a:defRPr sz="1000">
                 <a:solidFill>
                   <a:srgbClr val="000000"/>
@@ -8312,7 +8320,7 @@
             <a:r>
               <a:rPr sz="1950" b="1">
                 <a:solidFill>
-                  <a:srgbClr val="26ABA4"/>
+                  <a:srgbClr val="215138"/>
                 </a:solidFill>
                 <a:latin typeface="Helvetica Neue"/>
                 <a:ea typeface="Helvetica Neue"/>
@@ -9097,11 +9105,11 @@
             <a:avLst/>
           </a:prstGeom>
           <a:solidFill xmlns:a="http://schemas.openxmlformats.org/drawingml/2006/main">
-            <a:srgbClr val="F28E2B"/>
+            <a:srgbClr val="F09D46"/>
           </a:solidFill>
           <a:ln xmlns:a="http://schemas.openxmlformats.org/drawingml/2006/main" w="0">
             <a:solidFill>
-              <a:srgbClr val="F28E2B"/>
+              <a:srgbClr val="F09D46"/>
             </a:solidFill>
             <a:prstDash val="solid"/>
           </a:ln>

</xml_diff>